<commit_message>
feat: add TCL commands file
</commit_message>
<xml_diff>
--- a/Aula 03/ComandosBásicos.pptx
+++ b/Aula 03/ComandosBásicos.pptx
@@ -279,7 +279,7 @@
           <a:p>
             <a:fld id="{57FC07F7-71D6-4EB2-BB6B-DCE721D2C512}" type="datetimeFigureOut">
               <a:rPr lang="pt-BR" smtClean="0"/>
-              <a:t>18/02/2026</a:t>
+              <a:t>16/04/2026</a:t>
             </a:fld>
             <a:endParaRPr lang="pt-BR"/>
           </a:p>
@@ -477,7 +477,7 @@
           <a:p>
             <a:fld id="{57FC07F7-71D6-4EB2-BB6B-DCE721D2C512}" type="datetimeFigureOut">
               <a:rPr lang="pt-BR" smtClean="0"/>
-              <a:t>18/02/2026</a:t>
+              <a:t>16/04/2026</a:t>
             </a:fld>
             <a:endParaRPr lang="pt-BR"/>
           </a:p>
@@ -685,7 +685,7 @@
           <a:p>
             <a:fld id="{57FC07F7-71D6-4EB2-BB6B-DCE721D2C512}" type="datetimeFigureOut">
               <a:rPr lang="pt-BR" smtClean="0"/>
-              <a:t>18/02/2026</a:t>
+              <a:t>16/04/2026</a:t>
             </a:fld>
             <a:endParaRPr lang="pt-BR"/>
           </a:p>
@@ -883,7 +883,7 @@
           <a:p>
             <a:fld id="{57FC07F7-71D6-4EB2-BB6B-DCE721D2C512}" type="datetimeFigureOut">
               <a:rPr lang="pt-BR" smtClean="0"/>
-              <a:t>18/02/2026</a:t>
+              <a:t>16/04/2026</a:t>
             </a:fld>
             <a:endParaRPr lang="pt-BR"/>
           </a:p>
@@ -1158,7 +1158,7 @@
           <a:p>
             <a:fld id="{57FC07F7-71D6-4EB2-BB6B-DCE721D2C512}" type="datetimeFigureOut">
               <a:rPr lang="pt-BR" smtClean="0"/>
-              <a:t>18/02/2026</a:t>
+              <a:t>16/04/2026</a:t>
             </a:fld>
             <a:endParaRPr lang="pt-BR"/>
           </a:p>
@@ -1423,7 +1423,7 @@
           <a:p>
             <a:fld id="{57FC07F7-71D6-4EB2-BB6B-DCE721D2C512}" type="datetimeFigureOut">
               <a:rPr lang="pt-BR" smtClean="0"/>
-              <a:t>18/02/2026</a:t>
+              <a:t>16/04/2026</a:t>
             </a:fld>
             <a:endParaRPr lang="pt-BR"/>
           </a:p>
@@ -1835,7 +1835,7 @@
           <a:p>
             <a:fld id="{57FC07F7-71D6-4EB2-BB6B-DCE721D2C512}" type="datetimeFigureOut">
               <a:rPr lang="pt-BR" smtClean="0"/>
-              <a:t>18/02/2026</a:t>
+              <a:t>16/04/2026</a:t>
             </a:fld>
             <a:endParaRPr lang="pt-BR"/>
           </a:p>
@@ -1976,7 +1976,7 @@
           <a:p>
             <a:fld id="{57FC07F7-71D6-4EB2-BB6B-DCE721D2C512}" type="datetimeFigureOut">
               <a:rPr lang="pt-BR" smtClean="0"/>
-              <a:t>18/02/2026</a:t>
+              <a:t>16/04/2026</a:t>
             </a:fld>
             <a:endParaRPr lang="pt-BR"/>
           </a:p>
@@ -2089,7 +2089,7 @@
           <a:p>
             <a:fld id="{57FC07F7-71D6-4EB2-BB6B-DCE721D2C512}" type="datetimeFigureOut">
               <a:rPr lang="pt-BR" smtClean="0"/>
-              <a:t>18/02/2026</a:t>
+              <a:t>16/04/2026</a:t>
             </a:fld>
             <a:endParaRPr lang="pt-BR"/>
           </a:p>
@@ -2400,7 +2400,7 @@
           <a:p>
             <a:fld id="{57FC07F7-71D6-4EB2-BB6B-DCE721D2C512}" type="datetimeFigureOut">
               <a:rPr lang="pt-BR" smtClean="0"/>
-              <a:t>18/02/2026</a:t>
+              <a:t>16/04/2026</a:t>
             </a:fld>
             <a:endParaRPr lang="pt-BR"/>
           </a:p>
@@ -2688,7 +2688,7 @@
           <a:p>
             <a:fld id="{57FC07F7-71D6-4EB2-BB6B-DCE721D2C512}" type="datetimeFigureOut">
               <a:rPr lang="pt-BR" smtClean="0"/>
-              <a:t>18/02/2026</a:t>
+              <a:t>16/04/2026</a:t>
             </a:fld>
             <a:endParaRPr lang="pt-BR"/>
           </a:p>
@@ -2929,7 +2929,7 @@
           <a:p>
             <a:fld id="{57FC07F7-71D6-4EB2-BB6B-DCE721D2C512}" type="datetimeFigureOut">
               <a:rPr lang="pt-BR" smtClean="0"/>
-              <a:t>18/02/2026</a:t>
+              <a:t>16/04/2026</a:t>
             </a:fld>
             <a:endParaRPr lang="pt-BR"/>
           </a:p>
@@ -5568,62 +5568,6 @@
           </a:p>
         </p:txBody>
       </p:sp>
-      <p:sp>
-        <p:nvSpPr>
-          <p:cNvPr id="7" name="Símbolo de &quot;Não Permitido&quot; 6">
-            <a:extLst>
-              <a:ext uri="{FF2B5EF4-FFF2-40B4-BE49-F238E27FC236}">
-                <a16:creationId xmlns:a16="http://schemas.microsoft.com/office/drawing/2014/main" id="{AF4F76FA-5614-227F-C3F8-222E32F0BDFE}"/>
-              </a:ext>
-            </a:extLst>
-          </p:cNvPr>
-          <p:cNvSpPr/>
-          <p:nvPr/>
-        </p:nvSpPr>
-        <p:spPr>
-          <a:xfrm>
-            <a:off x="7765806" y="1855177"/>
-            <a:ext cx="2347546" cy="1784839"/>
-          </a:xfrm>
-          <a:prstGeom prst="noSmoking">
-            <a:avLst/>
-          </a:prstGeom>
-          <a:solidFill>
-            <a:schemeClr val="accent2">
-              <a:alpha val="50000"/>
-            </a:schemeClr>
-          </a:solidFill>
-          <a:ln>
-            <a:noFill/>
-          </a:ln>
-        </p:spPr>
-        <p:style>
-          <a:lnRef idx="0">
-            <a:scrgbClr r="0" g="0" b="0"/>
-          </a:lnRef>
-          <a:fillRef idx="0">
-            <a:scrgbClr r="0" g="0" b="0"/>
-          </a:fillRef>
-          <a:effectRef idx="0">
-            <a:scrgbClr r="0" g="0" b="0"/>
-          </a:effectRef>
-          <a:fontRef idx="minor">
-            <a:schemeClr val="lt1"/>
-          </a:fontRef>
-        </p:style>
-        <p:txBody>
-          <a:bodyPr rtlCol="0" anchor="ctr"/>
-          <a:lstStyle/>
-          <a:p>
-            <a:pPr algn="ctr"/>
-            <a:endParaRPr lang="pt-BR">
-              <a:solidFill>
-                <a:schemeClr val="tx1"/>
-              </a:solidFill>
-            </a:endParaRPr>
-          </a:p>
-        </p:txBody>
-      </p:sp>
     </p:spTree>
     <p:extLst>
       <p:ext uri="{BB962C8B-B14F-4D97-AF65-F5344CB8AC3E}">

</xml_diff>